<commit_message>
feat: add persistent factory data and classified documents
</commit_message>
<xml_diff>
--- a/demo_factory/documents/confidential/Failure_Analysis_S02.pptx
+++ b/demo_factory/documents/confidential/Failure_Analysis_S02.pptx
@@ -6,8 +6,15 @@
   </p:sldMasterIdLst>
   <p:sldIdLst>
     <p:sldId id="256" r:id="rId7"/>
+    <p:sldId id="257" r:id="rId8"/>
+    <p:sldId id="258" r:id="rId9"/>
+    <p:sldId id="259" r:id="rId10"/>
+    <p:sldId id="260" r:id="rId11"/>
+    <p:sldId id="261" r:id="rId12"/>
+    <p:sldId id="262" r:id="rId13"/>
+    <p:sldId id="263" r:id="rId14"/>
   </p:sldIdLst>
-  <p:sldSz cx="9144000" cy="6858000" type="screen4x3"/>
+  <p:sldSz cx="12191695" cy="6858000" type="screen4x3"/>
   <p:notesSz cx="6858000" cy="9144000"/>
   <p:defaultTextStyle>
     <a:defPPr>
@@ -105,6 +112,125 @@
     </a:lvl9pPr>
   </p:defaultTextStyle>
 </p:presentation>
+</file>
+
+<file path=ppt/charts/chart1.xml><?xml version="1.0" encoding="utf-8"?>
+<c:chartSpace xmlns:c="http://schemas.openxmlformats.org/drawingml/2006/chart" xmlns:a="http://schemas.openxmlformats.org/drawingml/2006/main" xmlns:r="http://schemas.openxmlformats.org/officeDocument/2006/relationships">
+  <c:date1904 val="0"/>
+  <c:chart>
+    <c:autoTitleDeleted val="0"/>
+    <c:plotArea>
+      <c:barChart>
+        <c:barDir val="col"/>
+        <c:grouping val="clustered"/>
+        <c:ser>
+          <c:idx val="0"/>
+          <c:order val="0"/>
+          <c:tx>
+            <c:strRef>
+              <c:f>Sheet1!$B$1</c:f>
+              <c:strCache>
+                <c:ptCount val="1"/>
+                <c:pt idx="0">
+                  <c:v>S02 positioning warnings</c:v>
+                </c:pt>
+              </c:strCache>
+            </c:strRef>
+          </c:tx>
+          <c:cat>
+            <c:strRef>
+              <c:f>Sheet1!$A$2:$A$5</c:f>
+              <c:strCache>
+                <c:ptCount val="4"/>
+                <c:pt idx="0">
+                  <c:v>08:00</c:v>
+                </c:pt>
+                <c:pt idx="1">
+                  <c:v>08:11</c:v>
+                </c:pt>
+                <c:pt idx="2">
+                  <c:v>08:22</c:v>
+                </c:pt>
+                <c:pt idx="3">
+                  <c:v>08:33</c:v>
+                </c:pt>
+              </c:strCache>
+            </c:strRef>
+          </c:cat>
+          <c:val>
+            <c:numRef>
+              <c:f>Sheet1!$B$2:$B$5</c:f>
+              <c:numCache>
+                <c:formatCode>General</c:formatCode>
+                <c:ptCount val="4"/>
+                <c:pt idx="0">
+                  <c:v>1</c:v>
+                </c:pt>
+                <c:pt idx="1">
+                  <c:v>1</c:v>
+                </c:pt>
+                <c:pt idx="2">
+                  <c:v>1</c:v>
+                </c:pt>
+                <c:pt idx="3">
+                  <c:v>1</c:v>
+                </c:pt>
+              </c:numCache>
+            </c:numRef>
+          </c:val>
+        </c:ser>
+        <c:axId val="-2068027336"/>
+        <c:axId val="-2113994440"/>
+      </c:barChart>
+      <c:catAx>
+        <c:axId val="-2068027336"/>
+        <c:scaling>
+          <c:orientation val="minMax"/>
+        </c:scaling>
+        <c:delete val="0"/>
+        <c:axPos val="b"/>
+        <c:majorTickMark val="out"/>
+        <c:minorTickMark val="none"/>
+        <c:tickLblPos val="nextTo"/>
+        <c:crossAx val="-2113994440"/>
+        <c:crosses val="autoZero"/>
+        <c:auto val="1"/>
+        <c:lblAlgn val="ctr"/>
+        <c:lblOffset val="100"/>
+        <c:noMultiLvlLbl val="0"/>
+      </c:catAx>
+      <c:valAx>
+        <c:axId val="-2113994440"/>
+        <c:scaling>
+          <c:max val="2.0"/>
+          <c:min val="0.0"/>
+        </c:scaling>
+        <c:delete val="0"/>
+        <c:axPos val="l"/>
+        <c:majorGridlines/>
+        <c:majorTickMark val="out"/>
+        <c:minorTickMark val="none"/>
+        <c:tickLblPos val="nextTo"/>
+        <c:crossAx val="-2068027336"/>
+        <c:crosses val="autoZero"/>
+      </c:valAx>
+    </c:plotArea>
+    <c:dispBlanksAs val="gap"/>
+  </c:chart>
+  <c:txPr>
+    <a:bodyPr/>
+    <a:lstStyle/>
+    <a:p>
+      <a:pPr>
+        <a:defRPr sz="1800"/>
+      </a:pPr>
+      <a:endParaRPr lang="en-US"/>
+    </a:p>
+  </c:txPr>
+  <c:externalData r:id="rId1">
+    <c:autoUpdate val="0"/>
+  </c:externalData>
+</c:chartSpace>
 </file>
 
 <file path=ppt/slideLayouts/slideLayout1.xml><?xml version="1.0" encoding="utf-8"?>
@@ -3095,6 +3221,66 @@
             <a:spLocks noGrp="1"/>
           </p:cNvSpPr>
           <p:nvPr>
+            <p:ph type="ctrTitle"/>
+          </p:nvPr>
+        </p:nvSpPr>
+        <p:spPr/>
+        <p:txBody>
+          <a:bodyPr/>
+          <a:lstStyle/>
+          <a:p>
+            <a:r>
+              <a:t>Failure Analysis S02</a:t>
+            </a:r>
+          </a:p>
+        </p:txBody>
+      </p:sp>
+      <p:sp>
+        <p:nvSpPr>
+          <p:cNvPr id="3" name="Subtitle 2"/>
+          <p:cNvSpPr>
+            <a:spLocks noGrp="1"/>
+          </p:cNvSpPr>
+          <p:nvPr>
+            <p:ph type="subTitle" idx="1"/>
+          </p:nvPr>
+        </p:nvSpPr>
+        <p:spPr/>
+        <p:txBody>
+          <a:bodyPr/>
+          <a:lstStyle/>
+          <a:p>
+            <a:r>
+              <a:t>FA-322 | FACTORY-DEMO-01 | Classification: CONFIDENTIAL | Revision 1.1</a:t>
+            </a:r>
+          </a:p>
+        </p:txBody>
+      </p:sp>
+    </p:spTree>
+  </p:cSld>
+  <p:clrMapOvr>
+    <a:masterClrMapping/>
+  </p:clrMapOvr>
+</p:sld>
+</file>
+
+<file path=ppt/slides/slide2.xml><?xml version="1.0" encoding="utf-8"?>
+<p:sld xmlns:a="http://schemas.openxmlformats.org/drawingml/2006/main" xmlns:p="http://schemas.openxmlformats.org/presentationml/2006/main" xmlns:r="http://schemas.openxmlformats.org/officeDocument/2006/relationships">
+  <p:cSld>
+    <p:spTree>
+      <p:nvGrpSpPr>
+        <p:cNvPr id="1" name=""/>
+        <p:cNvGrpSpPr/>
+        <p:nvPr/>
+      </p:nvGrpSpPr>
+      <p:grpSpPr/>
+      <p:sp>
+        <p:nvSpPr>
+          <p:cNvPr id="2" name="Title 1"/>
+          <p:cNvSpPr>
+            <a:spLocks noGrp="1"/>
+          </p:cNvSpPr>
+          <p:nvPr>
             <p:ph type="title"/>
           </p:nvPr>
         </p:nvSpPr>
@@ -3104,7 +3290,7 @@
           <a:lstStyle/>
           <a:p>
             <a:r>
-              <a:t>Failure Analysis S02</a:t>
+              <a:t>Incident Summary</a:t>
             </a:r>
           </a:p>
         </p:txBody>
@@ -3125,7 +3311,478 @@
           <a:lstStyle/>
           <a:p>
             <a:r>
-              <a:t>P4801 P4802 P4805 P4811 repeated station failure</a:t>
+              <a:t>Repeated S02 positioning warnings</a:t>
+            </a:r>
+          </a:p>
+          <a:p>
+            <a:r>
+              <a:t>Affected products: P4801, P4802, P4805, P4811</a:t>
+            </a:r>
+          </a:p>
+          <a:p>
+            <a:r>
+              <a:t>Related code: POSITION-ENC-02</a:t>
+            </a:r>
+          </a:p>
+        </p:txBody>
+      </p:sp>
+    </p:spTree>
+  </p:cSld>
+  <p:clrMapOvr>
+    <a:masterClrMapping/>
+  </p:clrMapOvr>
+</p:sld>
+</file>
+
+<file path=ppt/slides/slide3.xml><?xml version="1.0" encoding="utf-8"?>
+<p:sld xmlns:a="http://schemas.openxmlformats.org/drawingml/2006/main" xmlns:p="http://schemas.openxmlformats.org/presentationml/2006/main" xmlns:r="http://schemas.openxmlformats.org/officeDocument/2006/relationships">
+  <p:cSld>
+    <p:spTree>
+      <p:nvGrpSpPr>
+        <p:cNvPr id="1" name=""/>
+        <p:cNvGrpSpPr/>
+        <p:nvPr/>
+      </p:nvGrpSpPr>
+      <p:grpSpPr/>
+      <p:sp>
+        <p:nvSpPr>
+          <p:cNvPr id="2" name="Title 1"/>
+          <p:cNvSpPr>
+            <a:spLocks noGrp="1"/>
+          </p:cNvSpPr>
+          <p:nvPr>
+            <p:ph type="title"/>
+          </p:nvPr>
+        </p:nvSpPr>
+        <p:spPr/>
+        <p:txBody>
+          <a:bodyPr/>
+          <a:lstStyle/>
+          <a:p>
+            <a:r>
+              <a:t>Failure Trend</a:t>
+            </a:r>
+          </a:p>
+        </p:txBody>
+      </p:sp>
+      <p:graphicFrame>
+        <p:nvGraphicFramePr>
+          <p:cNvPr id="3" name="Chart 2"/>
+          <p:cNvGraphicFramePr>
+            <a:graphicFrameLocks noGrp="1"/>
+          </p:cNvGraphicFramePr>
+          <p:nvPr/>
+        </p:nvGraphicFramePr>
+        <p:xfrm>
+          <a:off x="914400" y="1371600"/>
+          <a:ext cx="7315200" cy="4114800"/>
+        </p:xfrm>
+        <a:graphic>
+          <a:graphicData uri="http://schemas.openxmlformats.org/drawingml/2006/chart">
+            <c:chart xmlns:c="http://schemas.openxmlformats.org/drawingml/2006/chart" r:id="rId2"/>
+          </a:graphicData>
+        </a:graphic>
+      </p:graphicFrame>
+      <p:sp>
+        <p:nvSpPr>
+          <p:cNvPr id="4" name="TextBox 3"/>
+          <p:cNvSpPr txBox="1"/>
+          <p:nvPr/>
+        </p:nvSpPr>
+        <p:spPr>
+          <a:xfrm>
+            <a:off x="8503920" y="1737360"/>
+            <a:ext cx="2743200" cy="2286000"/>
+          </a:xfrm>
+          <a:prstGeom prst="rect">
+            <a:avLst/>
+          </a:prstGeom>
+          <a:noFill/>
+        </p:spPr>
+        <p:txBody>
+          <a:bodyPr wrap="none">
+            <a:spAutoFit/>
+          </a:bodyPr>
+          <a:lstStyle/>
+          <a:p>
+            <a:r>
+              <a:t>Four warnings in 33 minutes</a:t>
+            </a:r>
+          </a:p>
+          <a:p/>
+          <a:p>
+            <a:r>
+              <a:t>Pattern indicates a station condition, not isolated product variation.</a:t>
+            </a:r>
+          </a:p>
+        </p:txBody>
+      </p:sp>
+    </p:spTree>
+  </p:cSld>
+  <p:clrMapOvr>
+    <a:masterClrMapping/>
+  </p:clrMapOvr>
+</p:sld>
+</file>
+
+<file path=ppt/slides/slide4.xml><?xml version="1.0" encoding="utf-8"?>
+<p:sld xmlns:a="http://schemas.openxmlformats.org/drawingml/2006/main" xmlns:p="http://schemas.openxmlformats.org/presentationml/2006/main" xmlns:r="http://schemas.openxmlformats.org/officeDocument/2006/relationships">
+  <p:cSld>
+    <p:spTree>
+      <p:nvGrpSpPr>
+        <p:cNvPr id="1" name=""/>
+        <p:cNvGrpSpPr/>
+        <p:nvPr/>
+      </p:nvGrpSpPr>
+      <p:grpSpPr/>
+      <p:sp>
+        <p:nvSpPr>
+          <p:cNvPr id="2" name="Title 1"/>
+          <p:cNvSpPr>
+            <a:spLocks noGrp="1"/>
+          </p:cNvSpPr>
+          <p:nvPr>
+            <p:ph type="title"/>
+          </p:nvPr>
+        </p:nvSpPr>
+        <p:spPr/>
+        <p:txBody>
+          <a:bodyPr/>
+          <a:lstStyle/>
+          <a:p>
+            <a:r>
+              <a:t>Affected Products</a:t>
+            </a:r>
+          </a:p>
+        </p:txBody>
+      </p:sp>
+      <p:sp>
+        <p:nvSpPr>
+          <p:cNvPr id="3" name="Content Placeholder 2"/>
+          <p:cNvSpPr>
+            <a:spLocks noGrp="1"/>
+          </p:cNvSpPr>
+          <p:nvPr>
+            <p:ph idx="1"/>
+          </p:nvPr>
+        </p:nvSpPr>
+        <p:spPr/>
+        <p:txBody>
+          <a:bodyPr/>
+          <a:lstStyle/>
+          <a:p>
+            <a:r>
+              <a:t>P4801 | 08:00</a:t>
+            </a:r>
+          </a:p>
+          <a:p>
+            <a:r>
+              <a:t>P4802 | 08:11</a:t>
+            </a:r>
+          </a:p>
+          <a:p>
+            <a:r>
+              <a:t>P4805 | 08:22</a:t>
+            </a:r>
+          </a:p>
+          <a:p>
+            <a:r>
+              <a:t>P4811 | 08:33</a:t>
+            </a:r>
+          </a:p>
+        </p:txBody>
+      </p:sp>
+    </p:spTree>
+  </p:cSld>
+  <p:clrMapOvr>
+    <a:masterClrMapping/>
+  </p:clrMapOvr>
+</p:sld>
+</file>
+
+<file path=ppt/slides/slide5.xml><?xml version="1.0" encoding="utf-8"?>
+<p:sld xmlns:a="http://schemas.openxmlformats.org/drawingml/2006/main" xmlns:p="http://schemas.openxmlformats.org/presentationml/2006/main" xmlns:r="http://schemas.openxmlformats.org/officeDocument/2006/relationships">
+  <p:cSld>
+    <p:spTree>
+      <p:nvGrpSpPr>
+        <p:cNvPr id="1" name=""/>
+        <p:cNvGrpSpPr/>
+        <p:nvPr/>
+      </p:nvGrpSpPr>
+      <p:grpSpPr/>
+      <p:sp>
+        <p:nvSpPr>
+          <p:cNvPr id="2" name="Title 1"/>
+          <p:cNvSpPr>
+            <a:spLocks noGrp="1"/>
+          </p:cNvSpPr>
+          <p:nvPr>
+            <p:ph type="title"/>
+          </p:nvPr>
+        </p:nvSpPr>
+        <p:spPr/>
+        <p:txBody>
+          <a:bodyPr/>
+          <a:lstStyle/>
+          <a:p>
+            <a:r>
+              <a:t>Event Timeline</a:t>
+            </a:r>
+          </a:p>
+        </p:txBody>
+      </p:sp>
+      <p:sp>
+        <p:nvSpPr>
+          <p:cNvPr id="3" name="Content Placeholder 2"/>
+          <p:cNvSpPr>
+            <a:spLocks noGrp="1"/>
+          </p:cNvSpPr>
+          <p:nvPr>
+            <p:ph idx="1"/>
+          </p:nvPr>
+        </p:nvSpPr>
+        <p:spPr/>
+        <p:txBody>
+          <a:bodyPr/>
+          <a:lstStyle/>
+          <a:p>
+            <a:r>
+              <a:t>08:35 E-STOP-17 escalation</a:t>
+            </a:r>
+          </a:p>
+          <a:p>
+            <a:r>
+              <a:t>09:01 encoder replacement</a:t>
+            </a:r>
+          </a:p>
+          <a:p>
+            <a:r>
+              <a:t>09:02 homing</a:t>
+            </a:r>
+          </a:p>
+          <a:p>
+            <a:r>
+              <a:t>09:03 dry cycle</a:t>
+            </a:r>
+          </a:p>
+          <a:p>
+            <a:r>
+              <a:t>09:04 inspection verification</a:t>
+            </a:r>
+          </a:p>
+          <a:p>
+            <a:r>
+              <a:t>09:05 return to service</a:t>
+            </a:r>
+          </a:p>
+        </p:txBody>
+      </p:sp>
+    </p:spTree>
+  </p:cSld>
+  <p:clrMapOvr>
+    <a:masterClrMapping/>
+  </p:clrMapOvr>
+</p:sld>
+</file>
+
+<file path=ppt/slides/slide6.xml><?xml version="1.0" encoding="utf-8"?>
+<p:sld xmlns:a="http://schemas.openxmlformats.org/drawingml/2006/main" xmlns:p="http://schemas.openxmlformats.org/presentationml/2006/main" xmlns:r="http://schemas.openxmlformats.org/officeDocument/2006/relationships">
+  <p:cSld>
+    <p:spTree>
+      <p:nvGrpSpPr>
+        <p:cNvPr id="1" name=""/>
+        <p:cNvGrpSpPr/>
+        <p:nvPr/>
+      </p:nvGrpSpPr>
+      <p:grpSpPr/>
+      <p:sp>
+        <p:nvSpPr>
+          <p:cNvPr id="2" name="Title 1"/>
+          <p:cNvSpPr>
+            <a:spLocks noGrp="1"/>
+          </p:cNvSpPr>
+          <p:nvPr>
+            <p:ph type="title"/>
+          </p:nvPr>
+        </p:nvSpPr>
+        <p:spPr/>
+        <p:txBody>
+          <a:bodyPr/>
+          <a:lstStyle/>
+          <a:p>
+            <a:r>
+              <a:t>Root Cause Analysis</a:t>
+            </a:r>
+          </a:p>
+        </p:txBody>
+      </p:sp>
+      <p:sp>
+        <p:nvSpPr>
+          <p:cNvPr id="3" name="Content Placeholder 2"/>
+          <p:cNvSpPr>
+            <a:spLocks noGrp="1"/>
+          </p:cNvSpPr>
+          <p:nvPr>
+            <p:ph idx="1"/>
+          </p:nvPr>
+        </p:nvSpPr>
+        <p:spPr/>
+        <p:txBody>
+          <a:bodyPr/>
+          <a:lstStyle/>
+          <a:p>
+            <a:r>
+              <a:t>Encoder feedback drift caused unstable positioning reference</a:t>
+            </a:r>
+          </a:p>
+          <a:p>
+            <a:r>
+              <a:t>No restricted process recipe change was required</a:t>
+            </a:r>
+          </a:p>
+        </p:txBody>
+      </p:sp>
+    </p:spTree>
+  </p:cSld>
+  <p:clrMapOvr>
+    <a:masterClrMapping/>
+  </p:clrMapOvr>
+</p:sld>
+</file>
+
+<file path=ppt/slides/slide7.xml><?xml version="1.0" encoding="utf-8"?>
+<p:sld xmlns:a="http://schemas.openxmlformats.org/drawingml/2006/main" xmlns:p="http://schemas.openxmlformats.org/presentationml/2006/main" xmlns:r="http://schemas.openxmlformats.org/officeDocument/2006/relationships">
+  <p:cSld>
+    <p:spTree>
+      <p:nvGrpSpPr>
+        <p:cNvPr id="1" name=""/>
+        <p:cNvGrpSpPr/>
+        <p:nvPr/>
+      </p:nvGrpSpPr>
+      <p:grpSpPr/>
+      <p:sp>
+        <p:nvSpPr>
+          <p:cNvPr id="2" name="Title 1"/>
+          <p:cNvSpPr>
+            <a:spLocks noGrp="1"/>
+          </p:cNvSpPr>
+          <p:nvPr>
+            <p:ph type="title"/>
+          </p:nvPr>
+        </p:nvSpPr>
+        <p:spPr/>
+        <p:txBody>
+          <a:bodyPr/>
+          <a:lstStyle/>
+          <a:p>
+            <a:r>
+              <a:t>Corrective Actions</a:t>
+            </a:r>
+          </a:p>
+        </p:txBody>
+      </p:sp>
+      <p:sp>
+        <p:nvSpPr>
+          <p:cNvPr id="3" name="Content Placeholder 2"/>
+          <p:cNvSpPr>
+            <a:spLocks noGrp="1"/>
+          </p:cNvSpPr>
+          <p:nvPr>
+            <p:ph idx="1"/>
+          </p:nvPr>
+        </p:nvSpPr>
+        <p:spPr/>
+        <p:txBody>
+          <a:bodyPr/>
+          <a:lstStyle/>
+          <a:p>
+            <a:r>
+              <a:t>Replace encoder</a:t>
+            </a:r>
+          </a:p>
+          <a:p>
+            <a:r>
+              <a:t>Home station</a:t>
+            </a:r>
+          </a:p>
+          <a:p>
+            <a:r>
+              <a:t>Perform dry cycle</a:t>
+            </a:r>
+          </a:p>
+          <a:p>
+            <a:r>
+              <a:t>Verify inspection</a:t>
+            </a:r>
+          </a:p>
+          <a:p>
+            <a:r>
+              <a:t>Return to service with closed work order</a:t>
+            </a:r>
+          </a:p>
+        </p:txBody>
+      </p:sp>
+    </p:spTree>
+  </p:cSld>
+  <p:clrMapOvr>
+    <a:masterClrMapping/>
+  </p:clrMapOvr>
+</p:sld>
+</file>
+
+<file path=ppt/slides/slide8.xml><?xml version="1.0" encoding="utf-8"?>
+<p:sld xmlns:a="http://schemas.openxmlformats.org/drawingml/2006/main" xmlns:p="http://schemas.openxmlformats.org/presentationml/2006/main" xmlns:r="http://schemas.openxmlformats.org/officeDocument/2006/relationships">
+  <p:cSld>
+    <p:spTree>
+      <p:nvGrpSpPr>
+        <p:cNvPr id="1" name=""/>
+        <p:cNvGrpSpPr/>
+        <p:nvPr/>
+      </p:nvGrpSpPr>
+      <p:grpSpPr/>
+      <p:sp>
+        <p:nvSpPr>
+          <p:cNvPr id="2" name="Title 1"/>
+          <p:cNvSpPr>
+            <a:spLocks noGrp="1"/>
+          </p:cNvSpPr>
+          <p:nvPr>
+            <p:ph type="title"/>
+          </p:nvPr>
+        </p:nvSpPr>
+        <p:spPr/>
+        <p:txBody>
+          <a:bodyPr/>
+          <a:lstStyle/>
+          <a:p>
+            <a:r>
+              <a:t>Verification and Conclusion</a:t>
+            </a:r>
+          </a:p>
+        </p:txBody>
+      </p:sp>
+      <p:sp>
+        <p:nvSpPr>
+          <p:cNvPr id="3" name="Content Placeholder 2"/>
+          <p:cNvSpPr>
+            <a:spLocks noGrp="1"/>
+          </p:cNvSpPr>
+          <p:nvPr>
+            <p:ph idx="1"/>
+          </p:nvPr>
+        </p:nvSpPr>
+        <p:spPr/>
+        <p:txBody>
+          <a:bodyPr/>
+          <a:lstStyle/>
+          <a:p>
+            <a:r>
+              <a:t>Reference deviation reduced from 0.84 mm to 0.06 mm</a:t>
+            </a:r>
+          </a:p>
+          <a:p>
+            <a:r>
+              <a:t>No repeat POSITION-ENC-02 after verification</a:t>
             </a:r>
           </a:p>
         </p:txBody>

</xml_diff>